<commit_message>
feat: PPTX from live data, exec summaries, data confidence tag, naive baseline table
- pptx_generator.py: Slides 3/4/5 now built from real scores/mc/mc_v2/cluster/dag_info
  (no hardcoded OTK/JDE/D&B strings; MC numbers from actual pipeline, not literals)
- report_writer.py: added _data_confidence_tag, _naive_baseline_section, write_exec_summary
  write_report now emits confidence tier + naive-vs-model baseline table per report
- main.py: run_project returns (path, pipeline_dict); run_all collects live_data,
  auto-generates exec summaries (outputs/exec/) and PPTX after every full run
- outputs/exec/: two one-page exec summaries with RAG, reason, P(on-time), action, confidence
</commit_message>
<xml_diff>
--- a/outputs/monthly/Executive_Report_2026-07.pptx
+++ b/outputs/monthly/Executive_Report_2026-07.pptx
@@ -3506,7 +3506,7 @@
               </a:defRPr>
             </a:pPr>
             <a:r>
-              <a:t>Cross-Project Trend Analysis</a:t>
+              <a:t>Cross-Project Health &amp; Naive Baseline</a:t>
             </a:r>
           </a:p>
         </p:txBody>
@@ -3555,7 +3555,7 @@
         <p:spPr>
           <a:xfrm>
             <a:off x="365760" y="1371600"/>
-            <a:ext cx="4114800" cy="411480"/>
+            <a:ext cx="3657600" cy="411480"/>
           </a:xfrm>
           <a:prstGeom prst="rect">
             <a:avLst/>
@@ -3576,7 +3576,7 @@
               </a:defRPr>
             </a:pPr>
             <a:r>
-              <a:t>Outokumpu S2P</a:t>
+              <a:t>🟡 Outokumpu S2P</a:t>
             </a:r>
           </a:p>
         </p:txBody>
@@ -3589,8 +3589,8 @@
         </p:nvSpPr>
         <p:spPr>
           <a:xfrm>
-            <a:off x="4572000" y="1417320"/>
-            <a:ext cx="1920239" cy="320040"/>
+            <a:off x="4114800" y="1417320"/>
+            <a:ext cx="2011862" cy="320040"/>
           </a:xfrm>
           <a:prstGeom prst="rect">
             <a:avLst/>
@@ -3632,8 +3632,8 @@
         </p:nvSpPr>
         <p:spPr>
           <a:xfrm>
-            <a:off x="4572000" y="1755648"/>
-            <a:ext cx="6400800" cy="320040"/>
+            <a:off x="4114800" y="1755648"/>
+            <a:ext cx="7589520" cy="320040"/>
           </a:xfrm>
           <a:prstGeom prst="rect">
             <a:avLst/>
@@ -3654,7 +3654,7 @@
               </a:defRPr>
             </a:pPr>
             <a:r>
-              <a:t>Score: 0.37  |  P(on-time): 77%</a:t>
+              <a:t>Score: 0.37/1.00   P(on-time): 78%</a:t>
             </a:r>
           </a:p>
         </p:txBody>
@@ -3668,7 +3668,7 @@
         <p:spPr>
           <a:xfrm>
             <a:off x="365760" y="2606040"/>
-            <a:ext cx="4114800" cy="411480"/>
+            <a:ext cx="3657600" cy="411480"/>
           </a:xfrm>
           <a:prstGeom prst="rect">
             <a:avLst/>
@@ -3689,7 +3689,7 @@
               </a:defRPr>
             </a:pPr>
             <a:r>
-              <a:t>UniSan S2P</a:t>
+              <a:t>🟢 UniSan S2P</a:t>
             </a:r>
           </a:p>
         </p:txBody>
@@ -3702,8 +3702,8 @@
         </p:nvSpPr>
         <p:spPr>
           <a:xfrm>
-            <a:off x="4572000" y="2651760"/>
-            <a:ext cx="0" cy="320040"/>
+            <a:off x="4114800" y="2651760"/>
+            <a:ext cx="212323" cy="320040"/>
           </a:xfrm>
           <a:prstGeom prst="rect">
             <a:avLst/>
@@ -3745,8 +3745,8 @@
         </p:nvSpPr>
         <p:spPr>
           <a:xfrm>
-            <a:off x="4572000" y="2990088"/>
-            <a:ext cx="6400800" cy="320040"/>
+            <a:off x="4114800" y="2990088"/>
+            <a:ext cx="7589520" cy="320040"/>
           </a:xfrm>
           <a:prstGeom prst="rect">
             <a:avLst/>
@@ -3767,7 +3767,7 @@
               </a:defRPr>
             </a:pPr>
             <a:r>
-              <a:t>Score: 0.04  |  P(on-time): 5%</a:t>
+              <a:t>Score: 0.04/1.00   P(on-time) DAG: 15%  |  v1: 5%</a:t>
             </a:r>
           </a:p>
         </p:txBody>
@@ -3795,14 +3795,14 @@
           <a:lstStyle/>
           <a:p>
             <a:pPr>
-              <a:defRPr sz="1300" b="0">
+              <a:defRPr sz="1200" b="0">
                 <a:solidFill>
                   <a:srgbClr val="1A2F5E"/>
                 </a:solidFill>
               </a:defRPr>
             </a:pPr>
             <a:r>
-              <a:t>Portfolio avg score: 0.20/1.00 — 0 of 2 projects currently Red. Both projects carry high At-Risk designation with critical-path slippage.</a:t>
+              <a:t>Portfolio avg score: 0.20/1.00 — 0/2 project(s) Red.  Monte Carlo P(on-time) accounts for task velocity and variance — not just % complete. See Slide 4 for model comparison.</a:t>
             </a:r>
           </a:p>
         </p:txBody>
@@ -3898,7 +3898,7 @@
               </a:defRPr>
             </a:pPr>
             <a:r>
-              <a:t>🔴  UniSan S2P — RED status: 44% complete at Training Phase I; 175 tasks Not Started, 35 in parallel. Schedule variance -8 working days at project level.</a:t>
+              <a:t>🟡  Outokumpu S2P — AMBER: 54 active at-risk tasks, 60 Red. Top cluster: 28 tasks under abhilasha.s@zycus.com. 78% P(on-time).</a:t>
             </a:r>
           </a:p>
         </p:txBody>
@@ -3911,7 +3911,7 @@
         </p:nvSpPr>
         <p:spPr>
           <a:xfrm>
-            <a:off x="457200" y="1828800"/>
+            <a:off x="457200" y="1810512"/>
             <a:ext cx="11247120" cy="685800"/>
           </a:xfrm>
           <a:prstGeom prst="rect">
@@ -3933,7 +3933,7 @@
               </a:defRPr>
             </a:pPr>
             <a:r>
-              <a:t>🟡  Outokumpu S2P — AMBER watch: Phase 1 S2C slipping 6 working days. iSupplier deployment 32 days behind. 2 tasks on hold (D&amp;B creds, supplier notifications).</a:t>
+              <a:t>🟢  UniSan S2P — GREEN: 51 active at-risk tasks, 42 Red. Top cluster: 26 tasks under UniSan Integration Team. 5% P(on-time).</a:t>
             </a:r>
           </a:p>
         </p:txBody>
@@ -3946,7 +3946,7 @@
         </p:nvSpPr>
         <p:spPr>
           <a:xfrm>
-            <a:off x="457200" y="2651760"/>
+            <a:off x="457200" y="2615184"/>
             <a:ext cx="11247120" cy="685800"/>
           </a:xfrm>
           <a:prstGeom prst="rect">
@@ -3968,7 +3968,7 @@
               </a:defRPr>
             </a:pPr>
             <a:r>
-              <a:t>⚠️  Common pattern across both projects: at-risk tasks cluster around integration &amp; data configuration activities — a systemic readiness risk.</a:t>
+              <a:t>ℹ️  No projects currently Red. Continue monitoring Amber items and critical-path tasks.</a:t>
             </a:r>
           </a:p>
         </p:txBody>
@@ -3981,43 +3981,8 @@
         </p:nvSpPr>
         <p:spPr>
           <a:xfrm>
-            <a:off x="457200" y="3474720"/>
-            <a:ext cx="11247120" cy="685800"/>
-          </a:xfrm>
-          <a:prstGeom prst="rect">
-            <a:avLst/>
-          </a:prstGeom>
-          <a:noFill/>
-        </p:spPr>
-        <p:txBody>
-          <a:bodyPr wrap="square">
-            <a:spAutoFit/>
-          </a:bodyPr>
-          <a:lstStyle/>
-          <a:p>
-            <a:pPr>
-              <a:defRPr sz="1300" b="0">
-                <a:solidFill>
-                  <a:srgbClr val="222222"/>
-                </a:solidFill>
-              </a:defRPr>
-            </a:pPr>
-            <a:r>
-              <a:t>⚠️  Data dependency risk: OTK sample data not yet provided (due Jul 10). JDE mapping pending. Both items are on the critical path.</a:t>
-            </a:r>
-          </a:p>
-        </p:txBody>
-      </p:sp>
-      <p:sp>
-        <p:nvSpPr>
-          <p:cNvPr id="7" name="TextBox 6"/>
-          <p:cNvSpPr txBox="1"/>
-          <p:nvPr/>
-        </p:nvSpPr>
-        <p:spPr>
-          <a:xfrm>
-            <a:off x="365760" y="4572000"/>
-            <a:ext cx="10972800" cy="457200"/>
+            <a:off x="365760" y="4617720"/>
+            <a:ext cx="10972800" cy="411480"/>
           </a:xfrm>
           <a:prstGeom prst="rect">
             <a:avLst/>
@@ -4045,7 +4010,7 @@
       </p:sp>
       <p:sp>
         <p:nvSpPr>
-          <p:cNvPr id="8" name="Rectangle 7"/>
+          <p:cNvPr id="7" name="Rectangle 6"/>
           <p:cNvSpPr/>
           <p:nvPr/>
         </p:nvSpPr>
@@ -4088,7 +4053,7 @@
       </p:sp>
       <p:sp>
         <p:nvSpPr>
-          <p:cNvPr id="9" name="TextBox 8"/>
+          <p:cNvPr id="8" name="TextBox 7"/>
           <p:cNvSpPr txBox="1"/>
           <p:nvPr/>
         </p:nvSpPr>
@@ -4123,14 +4088,14 @@
       </p:sp>
       <p:sp>
         <p:nvSpPr>
-          <p:cNvPr id="10" name="Rectangle 9"/>
+          <p:cNvPr id="9" name="Rectangle 8"/>
           <p:cNvSpPr/>
           <p:nvPr/>
         </p:nvSpPr>
         <p:spPr>
           <a:xfrm>
             <a:off x="3200400" y="5074920"/>
-            <a:ext cx="2286000" cy="365760"/>
+            <a:ext cx="2011680" cy="365760"/>
           </a:xfrm>
           <a:prstGeom prst="rect">
             <a:avLst/>
@@ -4166,14 +4131,14 @@
       </p:sp>
       <p:sp>
         <p:nvSpPr>
-          <p:cNvPr id="11" name="TextBox 10"/>
+          <p:cNvPr id="10" name="TextBox 9"/>
           <p:cNvSpPr txBox="1"/>
           <p:nvPr/>
         </p:nvSpPr>
         <p:spPr>
           <a:xfrm>
             <a:off x="3246120" y="5102352"/>
-            <a:ext cx="2194560" cy="320040"/>
+            <a:ext cx="1920240" cy="320040"/>
           </a:xfrm>
           <a:prstGeom prst="rect">
             <a:avLst/>
@@ -4194,21 +4159,21 @@
               </a:defRPr>
             </a:pPr>
             <a:r>
-              <a:t>Active Risk Tasks</a:t>
-            </a:r>
-          </a:p>
-        </p:txBody>
-      </p:sp>
-      <p:sp>
-        <p:nvSpPr>
-          <p:cNvPr id="12" name="Rectangle 11"/>
+              <a:t>At-Risk Active</a:t>
+            </a:r>
+          </a:p>
+        </p:txBody>
+      </p:sp>
+      <p:sp>
+        <p:nvSpPr>
+          <p:cNvPr id="11" name="Rectangle 10"/>
           <p:cNvSpPr/>
           <p:nvPr/>
         </p:nvSpPr>
         <p:spPr>
           <a:xfrm>
-            <a:off x="5577840" y="5074920"/>
-            <a:ext cx="4114800" cy="365760"/>
+            <a:off x="5303520" y="5074920"/>
+            <a:ext cx="4846320" cy="365760"/>
           </a:xfrm>
           <a:prstGeom prst="rect">
             <a:avLst/>
@@ -4244,14 +4209,14 @@
       </p:sp>
       <p:sp>
         <p:nvSpPr>
-          <p:cNvPr id="13" name="TextBox 12"/>
-          <p:cNvSpPr txBox="1"/>
-          <p:nvPr/>
-        </p:nvSpPr>
-        <p:spPr>
-          <a:xfrm>
-            <a:off x="5623559" y="5102352"/>
-            <a:ext cx="4023360" cy="320040"/>
+          <p:cNvPr id="12" name="TextBox 11"/>
+          <p:cNvSpPr txBox="1"/>
+          <p:nvPr/>
+        </p:nvSpPr>
+        <p:spPr>
+          <a:xfrm>
+            <a:off x="5349240" y="5102352"/>
+            <a:ext cx="4754880" cy="320040"/>
           </a:xfrm>
           <a:prstGeom prst="rect">
             <a:avLst/>
@@ -4272,20 +4237,20 @@
               </a:defRPr>
             </a:pPr>
             <a:r>
-              <a:t>Top Risk Area</a:t>
-            </a:r>
-          </a:p>
-        </p:txBody>
-      </p:sp>
-      <p:sp>
-        <p:nvSpPr>
-          <p:cNvPr id="14" name="Rectangle 13"/>
+              <a:t>Top Owner / Cluster</a:t>
+            </a:r>
+          </a:p>
+        </p:txBody>
+      </p:sp>
+      <p:sp>
+        <p:nvSpPr>
+          <p:cNvPr id="13" name="Rectangle 12"/>
           <p:cNvSpPr/>
           <p:nvPr/>
         </p:nvSpPr>
         <p:spPr>
           <a:xfrm>
-            <a:off x="9784080" y="5074920"/>
+            <a:off x="10241280" y="5074920"/>
             <a:ext cx="1828800" cy="365760"/>
           </a:xfrm>
           <a:prstGeom prst="rect">
@@ -4322,13 +4287,13 @@
       </p:sp>
       <p:sp>
         <p:nvSpPr>
-          <p:cNvPr id="15" name="TextBox 14"/>
-          <p:cNvSpPr txBox="1"/>
-          <p:nvPr/>
-        </p:nvSpPr>
-        <p:spPr>
-          <a:xfrm>
-            <a:off x="9829800" y="5102352"/>
+          <p:cNvPr id="14" name="TextBox 13"/>
+          <p:cNvSpPr txBox="1"/>
+          <p:nvPr/>
+        </p:nvSpPr>
+        <p:spPr>
+          <a:xfrm>
+            <a:off x="10287000" y="5102352"/>
             <a:ext cx="1737360" cy="320040"/>
           </a:xfrm>
           <a:prstGeom prst="rect">
@@ -4350,7 +4315,287 @@
               </a:defRPr>
             </a:pPr>
             <a:r>
-              <a:t>Deadline P(on-time)</a:t>
+              <a:t>P(on-time)</a:t>
+            </a:r>
+          </a:p>
+        </p:txBody>
+      </p:sp>
+      <p:sp>
+        <p:nvSpPr>
+          <p:cNvPr id="15" name="TextBox 14"/>
+          <p:cNvSpPr txBox="1"/>
+          <p:nvPr/>
+        </p:nvSpPr>
+        <p:spPr>
+          <a:xfrm>
+            <a:off x="411480" y="5504688"/>
+            <a:ext cx="2651760" cy="347472"/>
+          </a:xfrm>
+          <a:prstGeom prst="rect">
+            <a:avLst/>
+          </a:prstGeom>
+          <a:noFill/>
+        </p:spPr>
+        <p:txBody>
+          <a:bodyPr wrap="square">
+            <a:spAutoFit/>
+          </a:bodyPr>
+          <a:lstStyle/>
+          <a:p>
+            <a:pPr>
+              <a:defRPr sz="1100" b="0">
+                <a:solidFill>
+                  <a:srgbClr val="222222"/>
+                </a:solidFill>
+              </a:defRPr>
+            </a:pPr>
+            <a:r>
+              <a:t>Outokumpu S2P</a:t>
+            </a:r>
+          </a:p>
+        </p:txBody>
+      </p:sp>
+      <p:sp>
+        <p:nvSpPr>
+          <p:cNvPr id="16" name="TextBox 15"/>
+          <p:cNvSpPr txBox="1"/>
+          <p:nvPr/>
+        </p:nvSpPr>
+        <p:spPr>
+          <a:xfrm>
+            <a:off x="3246120" y="5504688"/>
+            <a:ext cx="1920240" cy="347472"/>
+          </a:xfrm>
+          <a:prstGeom prst="rect">
+            <a:avLst/>
+          </a:prstGeom>
+          <a:noFill/>
+        </p:spPr>
+        <p:txBody>
+          <a:bodyPr wrap="square">
+            <a:spAutoFit/>
+          </a:bodyPr>
+          <a:lstStyle/>
+          <a:p>
+            <a:pPr>
+              <a:defRPr sz="1100" b="0">
+                <a:solidFill>
+                  <a:srgbClr val="222222"/>
+                </a:solidFill>
+              </a:defRPr>
+            </a:pPr>
+            <a:r>
+              <a:t>54</a:t>
+            </a:r>
+          </a:p>
+        </p:txBody>
+      </p:sp>
+      <p:sp>
+        <p:nvSpPr>
+          <p:cNvPr id="17" name="TextBox 16"/>
+          <p:cNvSpPr txBox="1"/>
+          <p:nvPr/>
+        </p:nvSpPr>
+        <p:spPr>
+          <a:xfrm>
+            <a:off x="5349240" y="5504688"/>
+            <a:ext cx="4754880" cy="347472"/>
+          </a:xfrm>
+          <a:prstGeom prst="rect">
+            <a:avLst/>
+          </a:prstGeom>
+          <a:noFill/>
+        </p:spPr>
+        <p:txBody>
+          <a:bodyPr wrap="square">
+            <a:spAutoFit/>
+          </a:bodyPr>
+          <a:lstStyle/>
+          <a:p>
+            <a:pPr>
+              <a:defRPr sz="1100" b="0">
+                <a:solidFill>
+                  <a:srgbClr val="222222"/>
+                </a:solidFill>
+              </a:defRPr>
+            </a:pPr>
+            <a:r>
+              <a:t>28 tasks / abhilasha.s@zycus.com</a:t>
+            </a:r>
+          </a:p>
+        </p:txBody>
+      </p:sp>
+      <p:sp>
+        <p:nvSpPr>
+          <p:cNvPr id="18" name="TextBox 17"/>
+          <p:cNvSpPr txBox="1"/>
+          <p:nvPr/>
+        </p:nvSpPr>
+        <p:spPr>
+          <a:xfrm>
+            <a:off x="10287000" y="5504688"/>
+            <a:ext cx="1737360" cy="347472"/>
+          </a:xfrm>
+          <a:prstGeom prst="rect">
+            <a:avLst/>
+          </a:prstGeom>
+          <a:noFill/>
+        </p:spPr>
+        <p:txBody>
+          <a:bodyPr wrap="square">
+            <a:spAutoFit/>
+          </a:bodyPr>
+          <a:lstStyle/>
+          <a:p>
+            <a:pPr>
+              <a:defRPr sz="1100" b="0">
+                <a:solidFill>
+                  <a:srgbClr val="222222"/>
+                </a:solidFill>
+              </a:defRPr>
+            </a:pPr>
+            <a:r>
+              <a:t>78%</a:t>
+            </a:r>
+          </a:p>
+        </p:txBody>
+      </p:sp>
+      <p:sp>
+        <p:nvSpPr>
+          <p:cNvPr id="19" name="TextBox 18"/>
+          <p:cNvSpPr txBox="1"/>
+          <p:nvPr/>
+        </p:nvSpPr>
+        <p:spPr>
+          <a:xfrm>
+            <a:off x="411480" y="5888736"/>
+            <a:ext cx="2651760" cy="347472"/>
+          </a:xfrm>
+          <a:prstGeom prst="rect">
+            <a:avLst/>
+          </a:prstGeom>
+          <a:noFill/>
+        </p:spPr>
+        <p:txBody>
+          <a:bodyPr wrap="square">
+            <a:spAutoFit/>
+          </a:bodyPr>
+          <a:lstStyle/>
+          <a:p>
+            <a:pPr>
+              <a:defRPr sz="1100" b="0">
+                <a:solidFill>
+                  <a:srgbClr val="222222"/>
+                </a:solidFill>
+              </a:defRPr>
+            </a:pPr>
+            <a:r>
+              <a:t>UniSan S2P</a:t>
+            </a:r>
+          </a:p>
+        </p:txBody>
+      </p:sp>
+      <p:sp>
+        <p:nvSpPr>
+          <p:cNvPr id="20" name="TextBox 19"/>
+          <p:cNvSpPr txBox="1"/>
+          <p:nvPr/>
+        </p:nvSpPr>
+        <p:spPr>
+          <a:xfrm>
+            <a:off x="3246120" y="5888736"/>
+            <a:ext cx="1920240" cy="347472"/>
+          </a:xfrm>
+          <a:prstGeom prst="rect">
+            <a:avLst/>
+          </a:prstGeom>
+          <a:noFill/>
+        </p:spPr>
+        <p:txBody>
+          <a:bodyPr wrap="square">
+            <a:spAutoFit/>
+          </a:bodyPr>
+          <a:lstStyle/>
+          <a:p>
+            <a:pPr>
+              <a:defRPr sz="1100" b="0">
+                <a:solidFill>
+                  <a:srgbClr val="222222"/>
+                </a:solidFill>
+              </a:defRPr>
+            </a:pPr>
+            <a:r>
+              <a:t>51</a:t>
+            </a:r>
+          </a:p>
+        </p:txBody>
+      </p:sp>
+      <p:sp>
+        <p:nvSpPr>
+          <p:cNvPr id="21" name="TextBox 20"/>
+          <p:cNvSpPr txBox="1"/>
+          <p:nvPr/>
+        </p:nvSpPr>
+        <p:spPr>
+          <a:xfrm>
+            <a:off x="5349240" y="5888736"/>
+            <a:ext cx="4754880" cy="347472"/>
+          </a:xfrm>
+          <a:prstGeom prst="rect">
+            <a:avLst/>
+          </a:prstGeom>
+          <a:noFill/>
+        </p:spPr>
+        <p:txBody>
+          <a:bodyPr wrap="square">
+            <a:spAutoFit/>
+          </a:bodyPr>
+          <a:lstStyle/>
+          <a:p>
+            <a:pPr>
+              <a:defRPr sz="1100" b="0">
+                <a:solidFill>
+                  <a:srgbClr val="222222"/>
+                </a:solidFill>
+              </a:defRPr>
+            </a:pPr>
+            <a:r>
+              <a:t>26 tasks / UniSan Integration Team</a:t>
+            </a:r>
+          </a:p>
+        </p:txBody>
+      </p:sp>
+      <p:sp>
+        <p:nvSpPr>
+          <p:cNvPr id="22" name="TextBox 21"/>
+          <p:cNvSpPr txBox="1"/>
+          <p:nvPr/>
+        </p:nvSpPr>
+        <p:spPr>
+          <a:xfrm>
+            <a:off x="10287000" y="5888736"/>
+            <a:ext cx="1737360" cy="347472"/>
+          </a:xfrm>
+          <a:prstGeom prst="rect">
+            <a:avLst/>
+          </a:prstGeom>
+          <a:noFill/>
+        </p:spPr>
+        <p:txBody>
+          <a:bodyPr wrap="square">
+            <a:spAutoFit/>
+          </a:bodyPr>
+          <a:lstStyle/>
+          <a:p>
+            <a:pPr>
+              <a:defRPr sz="1100" b="0">
+                <a:solidFill>
+                  <a:srgbClr val="222222"/>
+                </a:solidFill>
+              </a:defRPr>
+            </a:pPr>
+            <a:r>
+              <a:t>15% (DAG)</a:t>
             </a:r>
           </a:p>
         </p:txBody>
@@ -4425,7 +4670,7 @@
         <p:spPr>
           <a:xfrm>
             <a:off x="365760" y="868680"/>
-            <a:ext cx="11430000" cy="640080"/>
+            <a:ext cx="11430000" cy="594360"/>
           </a:xfrm>
           <a:prstGeom prst="rect">
             <a:avLst/>
@@ -4446,7 +4691,7 @@
               </a:defRPr>
             </a:pPr>
             <a:r>
-              <a:t>Monte Carlo simulation: 10,000 scenarios per project using historical task duration ratios (actual/planned) from completed tasks. Limitation: single-snapshot data — no weekly history. Treat as directional.</a:t>
+              <a:t>Monte Carlo: 10,000 scenarios per project using historical task duration ratios (actual/planned) from completed tasks. v2 (DAG) propagates durations through predecessor graph — respects sequencing structure.</a:t>
             </a:r>
           </a:p>
         </p:txBody>
@@ -4459,8 +4704,8 @@
         </p:nvSpPr>
         <p:spPr>
           <a:xfrm>
-            <a:off x="365760" y="1828800"/>
-            <a:ext cx="11430000" cy="1463040"/>
+            <a:off x="365760" y="1691640"/>
+            <a:ext cx="11430000" cy="1691640"/>
           </a:xfrm>
           <a:prstGeom prst="rect">
             <a:avLst/>
@@ -4504,7 +4749,7 @@
         </p:nvSpPr>
         <p:spPr>
           <a:xfrm>
-            <a:off x="548640" y="1920240"/>
+            <a:off x="548640" y="1783080"/>
             <a:ext cx="3657600" cy="411480"/>
           </a:xfrm>
           <a:prstGeom prst="rect">
@@ -4539,7 +4784,7 @@
         </p:nvSpPr>
         <p:spPr>
           <a:xfrm>
-            <a:off x="548640" y="2377440"/>
+            <a:off x="548640" y="2240280"/>
             <a:ext cx="3657600" cy="320040"/>
           </a:xfrm>
           <a:prstGeom prst="rect">
@@ -4561,7 +4806,7 @@
               </a:defRPr>
             </a:pPr>
             <a:r>
-              <a:t>Deadline: Dec 2026</a:t>
+              <a:t>Deadline: 2026-12-07</a:t>
             </a:r>
           </a:p>
         </p:txBody>
@@ -4574,8 +4819,8 @@
         </p:nvSpPr>
         <p:spPr>
           <a:xfrm>
-            <a:off x="4572000" y="1920240"/>
-            <a:ext cx="2011680" cy="320040"/>
+            <a:off x="548640" y="2651760"/>
+            <a:ext cx="10698480" cy="411480"/>
           </a:xfrm>
           <a:prstGeom prst="rect">
             <a:avLst/>
@@ -4591,6 +4836,41 @@
             <a:pPr>
               <a:defRPr sz="1100" b="0">
                 <a:solidFill>
+                  <a:srgbClr val="444444"/>
+                </a:solidFill>
+              </a:defRPr>
+            </a:pPr>
+            <a:r>
+              <a:t>v1 (throughput): 78%  |  v2 skipped (low predecessor coverage)</a:t>
+            </a:r>
+          </a:p>
+        </p:txBody>
+      </p:sp>
+      <p:sp>
+        <p:nvSpPr>
+          <p:cNvPr id="8" name="TextBox 7"/>
+          <p:cNvSpPr txBox="1"/>
+          <p:nvPr/>
+        </p:nvSpPr>
+        <p:spPr>
+          <a:xfrm>
+            <a:off x="4754880" y="1783080"/>
+            <a:ext cx="2011680" cy="320040"/>
+          </a:xfrm>
+          <a:prstGeom prst="rect">
+            <a:avLst/>
+          </a:prstGeom>
+          <a:noFill/>
+        </p:spPr>
+        <p:txBody>
+          <a:bodyPr wrap="square">
+            <a:spAutoFit/>
+          </a:bodyPr>
+          <a:lstStyle/>
+          <a:p>
+            <a:pPr>
+              <a:defRPr sz="1100" b="0">
+                <a:solidFill>
                   <a:srgbClr val="555555"/>
                 </a:solidFill>
               </a:defRPr>
@@ -4603,14 +4883,14 @@
       </p:sp>
       <p:sp>
         <p:nvSpPr>
-          <p:cNvPr id="8" name="TextBox 7"/>
-          <p:cNvSpPr txBox="1"/>
-          <p:nvPr/>
-        </p:nvSpPr>
-        <p:spPr>
-          <a:xfrm>
-            <a:off x="4572000" y="2286000"/>
-            <a:ext cx="2011680" cy="640080"/>
+          <p:cNvPr id="9" name="TextBox 8"/>
+          <p:cNvSpPr txBox="1"/>
+          <p:nvPr/>
+        </p:nvSpPr>
+        <p:spPr>
+          <a:xfrm>
+            <a:off x="4754880" y="2103120"/>
+            <a:ext cx="2011680" cy="594360"/>
           </a:xfrm>
           <a:prstGeom prst="rect">
             <a:avLst/>
@@ -4631,20 +4911,20 @@
               </a:defRPr>
             </a:pPr>
             <a:r>
-              <a:t>~62%</a:t>
-            </a:r>
-          </a:p>
-        </p:txBody>
-      </p:sp>
-      <p:sp>
-        <p:nvSpPr>
-          <p:cNvPr id="9" name="TextBox 8"/>
-          <p:cNvSpPr txBox="1"/>
-          <p:nvPr/>
-        </p:nvSpPr>
-        <p:spPr>
-          <a:xfrm>
-            <a:off x="6949440" y="1920240"/>
+              <a:t>78%</a:t>
+            </a:r>
+          </a:p>
+        </p:txBody>
+      </p:sp>
+      <p:sp>
+        <p:nvSpPr>
+          <p:cNvPr id="10" name="TextBox 9"/>
+          <p:cNvSpPr txBox="1"/>
+          <p:nvPr/>
+        </p:nvSpPr>
+        <p:spPr>
+          <a:xfrm>
+            <a:off x="6995160" y="1783080"/>
             <a:ext cx="2011680" cy="320040"/>
           </a:xfrm>
           <a:prstGeom prst="rect">
@@ -4673,14 +4953,14 @@
       </p:sp>
       <p:sp>
         <p:nvSpPr>
-          <p:cNvPr id="10" name="TextBox 9"/>
-          <p:cNvSpPr txBox="1"/>
-          <p:nvPr/>
-        </p:nvSpPr>
-        <p:spPr>
-          <a:xfrm>
-            <a:off x="6949440" y="2286000"/>
-            <a:ext cx="2011680" cy="640080"/>
+          <p:cNvPr id="11" name="TextBox 10"/>
+          <p:cNvSpPr txBox="1"/>
+          <p:nvPr/>
+        </p:nvSpPr>
+        <p:spPr>
+          <a:xfrm>
+            <a:off x="6995160" y="2103120"/>
+            <a:ext cx="2011680" cy="594360"/>
           </a:xfrm>
           <a:prstGeom prst="rect">
             <a:avLst/>
@@ -4701,20 +4981,20 @@
               </a:defRPr>
             </a:pPr>
             <a:r>
-              <a:t>~15%</a:t>
-            </a:r>
-          </a:p>
-        </p:txBody>
-      </p:sp>
-      <p:sp>
-        <p:nvSpPr>
-          <p:cNvPr id="11" name="TextBox 10"/>
-          <p:cNvSpPr txBox="1"/>
-          <p:nvPr/>
-        </p:nvSpPr>
-        <p:spPr>
-          <a:xfrm>
-            <a:off x="9326880" y="1920240"/>
+              <a:t>5%</a:t>
+            </a:r>
+          </a:p>
+        </p:txBody>
+      </p:sp>
+      <p:sp>
+        <p:nvSpPr>
+          <p:cNvPr id="12" name="TextBox 11"/>
+          <p:cNvSpPr txBox="1"/>
+          <p:nvPr/>
+        </p:nvSpPr>
+        <p:spPr>
+          <a:xfrm>
+            <a:off x="9235440" y="1783080"/>
             <a:ext cx="2011680" cy="320040"/>
           </a:xfrm>
           <a:prstGeom prst="rect">
@@ -4743,14 +5023,14 @@
       </p:sp>
       <p:sp>
         <p:nvSpPr>
-          <p:cNvPr id="12" name="TextBox 11"/>
-          <p:cNvSpPr txBox="1"/>
-          <p:nvPr/>
-        </p:nvSpPr>
-        <p:spPr>
-          <a:xfrm>
-            <a:off x="9326880" y="2286000"/>
-            <a:ext cx="2011680" cy="640080"/>
+          <p:cNvPr id="13" name="TextBox 12"/>
+          <p:cNvSpPr txBox="1"/>
+          <p:nvPr/>
+        </p:nvSpPr>
+        <p:spPr>
+          <a:xfrm>
+            <a:off x="9235440" y="2103120"/>
+            <a:ext cx="2011680" cy="594360"/>
           </a:xfrm>
           <a:prstGeom prst="rect">
             <a:avLst/>
@@ -4771,21 +5051,21 @@
               </a:defRPr>
             </a:pPr>
             <a:r>
-              <a:t>~11%</a:t>
-            </a:r>
-          </a:p>
-        </p:txBody>
-      </p:sp>
-      <p:sp>
-        <p:nvSpPr>
-          <p:cNvPr id="13" name="Rectangle 12"/>
+              <a:t>13%</a:t>
+            </a:r>
+          </a:p>
+        </p:txBody>
+      </p:sp>
+      <p:sp>
+        <p:nvSpPr>
+          <p:cNvPr id="14" name="Rectangle 13"/>
           <p:cNvSpPr/>
           <p:nvPr/>
         </p:nvSpPr>
         <p:spPr>
           <a:xfrm>
-            <a:off x="365760" y="3749039"/>
-            <a:ext cx="11430000" cy="1463040"/>
+            <a:off x="365760" y="3611880"/>
+            <a:ext cx="11430000" cy="1691640"/>
           </a:xfrm>
           <a:prstGeom prst="rect">
             <a:avLst/>
@@ -4795,7 +5075,7 @@
           </a:solidFill>
           <a:ln>
             <a:solidFill>
-              <a:srgbClr val="C0392B"/>
+              <a:srgbClr val="27AE60"/>
             </a:solidFill>
           </a:ln>
         </p:spPr>
@@ -4823,13 +5103,13 @@
       </p:sp>
       <p:sp>
         <p:nvSpPr>
-          <p:cNvPr id="14" name="TextBox 13"/>
-          <p:cNvSpPr txBox="1"/>
-          <p:nvPr/>
-        </p:nvSpPr>
-        <p:spPr>
-          <a:xfrm>
-            <a:off x="548640" y="3840479"/>
+          <p:cNvPr id="15" name="TextBox 14"/>
+          <p:cNvSpPr txBox="1"/>
+          <p:nvPr/>
+        </p:nvSpPr>
+        <p:spPr>
+          <a:xfrm>
+            <a:off x="548640" y="3703320"/>
             <a:ext cx="3657600" cy="411480"/>
           </a:xfrm>
           <a:prstGeom prst="rect">
@@ -4858,13 +5138,13 @@
       </p:sp>
       <p:sp>
         <p:nvSpPr>
-          <p:cNvPr id="15" name="TextBox 14"/>
-          <p:cNvSpPr txBox="1"/>
-          <p:nvPr/>
-        </p:nvSpPr>
-        <p:spPr>
-          <a:xfrm>
-            <a:off x="548640" y="4297679"/>
+          <p:cNvPr id="16" name="TextBox 15"/>
+          <p:cNvSpPr txBox="1"/>
+          <p:nvPr/>
+        </p:nvSpPr>
+        <p:spPr>
+          <a:xfrm>
+            <a:off x="548640" y="4160520"/>
             <a:ext cx="3657600" cy="320040"/>
           </a:xfrm>
           <a:prstGeom prst="rect">
@@ -4886,21 +5166,21 @@
               </a:defRPr>
             </a:pPr>
             <a:r>
-              <a:t>Deadline: Oct 2026</a:t>
-            </a:r>
-          </a:p>
-        </p:txBody>
-      </p:sp>
-      <p:sp>
-        <p:nvSpPr>
-          <p:cNvPr id="16" name="TextBox 15"/>
-          <p:cNvSpPr txBox="1"/>
-          <p:nvPr/>
-        </p:nvSpPr>
-        <p:spPr>
-          <a:xfrm>
-            <a:off x="4572000" y="3840479"/>
-            <a:ext cx="2011680" cy="320040"/>
+              <a:t>Deadline: 2026-10-09</a:t>
+            </a:r>
+          </a:p>
+        </p:txBody>
+      </p:sp>
+      <p:sp>
+        <p:nvSpPr>
+          <p:cNvPr id="17" name="TextBox 16"/>
+          <p:cNvSpPr txBox="1"/>
+          <p:nvPr/>
+        </p:nvSpPr>
+        <p:spPr>
+          <a:xfrm>
+            <a:off x="548640" y="4572000"/>
+            <a:ext cx="10698480" cy="411480"/>
           </a:xfrm>
           <a:prstGeom prst="rect">
             <a:avLst/>
@@ -4916,6 +5196,41 @@
             <a:pPr>
               <a:defRPr sz="1100" b="0">
                 <a:solidFill>
+                  <a:srgbClr val="444444"/>
+                </a:solidFill>
+              </a:defRPr>
+            </a:pPr>
+            <a:r>
+              <a:t>v1 (throughput): 5%  →  v2 (DAG): 15%  (+10 pp from dependency structure)</a:t>
+            </a:r>
+          </a:p>
+        </p:txBody>
+      </p:sp>
+      <p:sp>
+        <p:nvSpPr>
+          <p:cNvPr id="18" name="TextBox 17"/>
+          <p:cNvSpPr txBox="1"/>
+          <p:nvPr/>
+        </p:nvSpPr>
+        <p:spPr>
+          <a:xfrm>
+            <a:off x="4754880" y="3703320"/>
+            <a:ext cx="2011680" cy="320040"/>
+          </a:xfrm>
+          <a:prstGeom prst="rect">
+            <a:avLst/>
+          </a:prstGeom>
+          <a:noFill/>
+        </p:spPr>
+        <p:txBody>
+          <a:bodyPr wrap="square">
+            <a:spAutoFit/>
+          </a:bodyPr>
+          <a:lstStyle/>
+          <a:p>
+            <a:pPr>
+              <a:defRPr sz="1100" b="0">
+                <a:solidFill>
                   <a:srgbClr val="555555"/>
                 </a:solidFill>
               </a:defRPr>
@@ -4928,14 +5243,14 @@
       </p:sp>
       <p:sp>
         <p:nvSpPr>
-          <p:cNvPr id="17" name="TextBox 16"/>
-          <p:cNvSpPr txBox="1"/>
-          <p:nvPr/>
-        </p:nvSpPr>
-        <p:spPr>
-          <a:xfrm>
-            <a:off x="4572000" y="4206240"/>
-            <a:ext cx="2011680" cy="640080"/>
+          <p:cNvPr id="19" name="TextBox 18"/>
+          <p:cNvSpPr txBox="1"/>
+          <p:nvPr/>
+        </p:nvSpPr>
+        <p:spPr>
+          <a:xfrm>
+            <a:off x="4754880" y="4023360"/>
+            <a:ext cx="2011680" cy="594360"/>
           </a:xfrm>
           <a:prstGeom prst="rect">
             <a:avLst/>
@@ -4956,20 +5271,20 @@
               </a:defRPr>
             </a:pPr>
             <a:r>
-              <a:t>~34%</a:t>
-            </a:r>
-          </a:p>
-        </p:txBody>
-      </p:sp>
-      <p:sp>
-        <p:nvSpPr>
-          <p:cNvPr id="18" name="TextBox 17"/>
-          <p:cNvSpPr txBox="1"/>
-          <p:nvPr/>
-        </p:nvSpPr>
-        <p:spPr>
-          <a:xfrm>
-            <a:off x="6949440" y="3840479"/>
+              <a:t>5%</a:t>
+            </a:r>
+          </a:p>
+        </p:txBody>
+      </p:sp>
+      <p:sp>
+        <p:nvSpPr>
+          <p:cNvPr id="20" name="TextBox 19"/>
+          <p:cNvSpPr txBox="1"/>
+          <p:nvPr/>
+        </p:nvSpPr>
+        <p:spPr>
+          <a:xfrm>
+            <a:off x="6995160" y="3703320"/>
             <a:ext cx="2011680" cy="320040"/>
           </a:xfrm>
           <a:prstGeom prst="rect">
@@ -4998,14 +5313,14 @@
       </p:sp>
       <p:sp>
         <p:nvSpPr>
-          <p:cNvPr id="19" name="TextBox 18"/>
-          <p:cNvSpPr txBox="1"/>
-          <p:nvPr/>
-        </p:nvSpPr>
-        <p:spPr>
-          <a:xfrm>
-            <a:off x="6949440" y="4206240"/>
-            <a:ext cx="2011680" cy="640080"/>
+          <p:cNvPr id="21" name="TextBox 20"/>
+          <p:cNvSpPr txBox="1"/>
+          <p:nvPr/>
+        </p:nvSpPr>
+        <p:spPr>
+          <a:xfrm>
+            <a:off x="6995160" y="4023360"/>
+            <a:ext cx="2011680" cy="594360"/>
           </a:xfrm>
           <a:prstGeom prst="rect">
             <a:avLst/>
@@ -5026,20 +5341,20 @@
               </a:defRPr>
             </a:pPr>
             <a:r>
-              <a:t>~22%</a:t>
-            </a:r>
-          </a:p>
-        </p:txBody>
-      </p:sp>
-      <p:sp>
-        <p:nvSpPr>
-          <p:cNvPr id="20" name="TextBox 19"/>
-          <p:cNvSpPr txBox="1"/>
-          <p:nvPr/>
-        </p:nvSpPr>
-        <p:spPr>
-          <a:xfrm>
-            <a:off x="9326880" y="3840479"/>
+              <a:t>3%</a:t>
+            </a:r>
+          </a:p>
+        </p:txBody>
+      </p:sp>
+      <p:sp>
+        <p:nvSpPr>
+          <p:cNvPr id="22" name="TextBox 21"/>
+          <p:cNvSpPr txBox="1"/>
+          <p:nvPr/>
+        </p:nvSpPr>
+        <p:spPr>
+          <a:xfrm>
+            <a:off x="9235440" y="3703320"/>
             <a:ext cx="2011680" cy="320040"/>
           </a:xfrm>
           <a:prstGeom prst="rect">
@@ -5068,14 +5383,14 @@
       </p:sp>
       <p:sp>
         <p:nvSpPr>
-          <p:cNvPr id="21" name="TextBox 20"/>
-          <p:cNvSpPr txBox="1"/>
-          <p:nvPr/>
-        </p:nvSpPr>
-        <p:spPr>
-          <a:xfrm>
-            <a:off x="9326880" y="4206240"/>
-            <a:ext cx="2011680" cy="640080"/>
+          <p:cNvPr id="23" name="TextBox 22"/>
+          <p:cNvSpPr txBox="1"/>
+          <p:nvPr/>
+        </p:nvSpPr>
+        <p:spPr>
+          <a:xfrm>
+            <a:off x="9235440" y="4023360"/>
+            <a:ext cx="2011680" cy="594360"/>
           </a:xfrm>
           <a:prstGeom prst="rect">
             <a:avLst/>
@@ -5096,7 +5411,7 @@
               </a:defRPr>
             </a:pPr>
             <a:r>
-              <a:t>~31%</a:t>
+              <a:t>88%</a:t>
             </a:r>
           </a:p>
         </p:txBody>
@@ -5171,7 +5486,7 @@
         <p:spPr>
           <a:xfrm>
             <a:off x="457200" y="1005840"/>
-            <a:ext cx="2743200" cy="320040"/>
+            <a:ext cx="2651760" cy="320040"/>
           </a:xfrm>
           <a:prstGeom prst="rect">
             <a:avLst/>
@@ -5192,7 +5507,7 @@
               </a:defRPr>
             </a:pPr>
             <a:r>
-              <a:t>🔍 Finding 1</a:t>
+              <a:t>🔍 Deadline Risk</a:t>
             </a:r>
           </a:p>
         </p:txBody>
@@ -5205,8 +5520,8 @@
         </p:nvSpPr>
         <p:spPr>
           <a:xfrm>
-            <a:off x="3291840" y="1005840"/>
-            <a:ext cx="8412480" cy="502920"/>
+            <a:off x="3200400" y="1005840"/>
+            <a:ext cx="8503920" cy="502920"/>
           </a:xfrm>
           <a:prstGeom prst="rect">
             <a:avLst/>
@@ -5227,7 +5542,7 @@
               </a:defRPr>
             </a:pPr>
             <a:r>
-              <a:t>Integration &amp; data-prep activities are the dominant risk cluster across both projects. These tasks share owners and are on the critical path — a single resource bottleneck.</a:t>
+              <a:t>Outokumpu S2P is the highest-risk project (score 0.367). P(on-time) 78% (throughput model). Deadline: 2026-12-07.</a:t>
             </a:r>
           </a:p>
         </p:txBody>
@@ -5240,8 +5555,8 @@
         </p:nvSpPr>
         <p:spPr>
           <a:xfrm>
-            <a:off x="457200" y="1691640"/>
-            <a:ext cx="2743200" cy="320040"/>
+            <a:off x="457200" y="1719072"/>
+            <a:ext cx="2651760" cy="320040"/>
           </a:xfrm>
           <a:prstGeom prst="rect">
             <a:avLst/>
@@ -5262,7 +5577,7 @@
               </a:defRPr>
             </a:pPr>
             <a:r>
-              <a:t>🔍 Finding 2</a:t>
+              <a:t>🔍 Critical Path</a:t>
             </a:r>
           </a:p>
         </p:txBody>
@@ -5275,8 +5590,8 @@
         </p:nvSpPr>
         <p:spPr>
           <a:xfrm>
-            <a:off x="3291840" y="1691640"/>
-            <a:ext cx="8412480" cy="502920"/>
+            <a:off x="3200400" y="1719072"/>
+            <a:ext cx="8503920" cy="502920"/>
           </a:xfrm>
           <a:prstGeom prst="rect">
             <a:avLst/>
@@ -5297,7 +5612,7 @@
               </a:defRPr>
             </a:pPr>
             <a:r>
-              <a:t>UniSan is 10 percentage points behind expected completion for this date (44% actual vs ~54% expected). The gap is widening.</a:t>
+              <a:t>Outokumpu S2P: 0/15 PM-flagged CP tasks are Red.</a:t>
             </a:r>
           </a:p>
         </p:txBody>
@@ -5310,8 +5625,8 @@
         </p:nvSpPr>
         <p:spPr>
           <a:xfrm>
-            <a:off x="457200" y="2377440"/>
-            <a:ext cx="2743200" cy="320040"/>
+            <a:off x="457200" y="2432304"/>
+            <a:ext cx="2651760" cy="320040"/>
           </a:xfrm>
           <a:prstGeom prst="rect">
             <a:avLst/>
@@ -5332,7 +5647,7 @@
               </a:defRPr>
             </a:pPr>
             <a:r>
-              <a:t>🔍 Finding 3</a:t>
+              <a:t>🔍 Critical Path</a:t>
             </a:r>
           </a:p>
         </p:txBody>
@@ -5345,8 +5660,8 @@
         </p:nvSpPr>
         <p:spPr>
           <a:xfrm>
-            <a:off x="3291840" y="2377440"/>
-            <a:ext cx="8412480" cy="502920"/>
+            <a:off x="3200400" y="2432304"/>
+            <a:ext cx="8503920" cy="502920"/>
           </a:xfrm>
           <a:prstGeom prst="rect">
             <a:avLst/>
@@ -5367,7 +5682,7 @@
               </a:defRPr>
             </a:pPr>
             <a:r>
-              <a:t>Outokumpu's Phase 1 slippage of 6 working days has not yet impacted the Dec 2026 overall deadline — but the iSupplier deployment at -32 days is the key watch item.</a:t>
+              <a:t>UniSan S2P: 2/50 PM-flagged CP tasks are Red; graph-computed CP = 50 tasks (74% predecessor coverage).</a:t>
             </a:r>
           </a:p>
         </p:txBody>
@@ -5380,7 +5695,7 @@
         </p:nvSpPr>
         <p:spPr>
           <a:xfrm>
-            <a:off x="365760" y="3246120"/>
+            <a:off x="365760" y="3282696"/>
             <a:ext cx="10972800" cy="411480"/>
           </a:xfrm>
           <a:prstGeom prst="rect">
@@ -5415,8 +5730,8 @@
         </p:nvSpPr>
         <p:spPr>
           <a:xfrm>
-            <a:off x="457200" y="3749040"/>
-            <a:ext cx="2743200" cy="320040"/>
+            <a:off x="457200" y="3785616"/>
+            <a:ext cx="2651760" cy="320040"/>
           </a:xfrm>
           <a:prstGeom prst="rect">
             <a:avLst/>
@@ -5437,7 +5752,7 @@
               </a:defRPr>
             </a:pPr>
             <a:r>
-              <a:t>✅ Action 1</a:t>
+              <a:t>✅ Outokumpu S2P</a:t>
             </a:r>
           </a:p>
         </p:txBody>
@@ -5450,8 +5765,8 @@
         </p:nvSpPr>
         <p:spPr>
           <a:xfrm>
-            <a:off x="3291840" y="3749040"/>
-            <a:ext cx="8412480" cy="502920"/>
+            <a:off x="3200400" y="3785616"/>
+            <a:ext cx="8503920" cy="502920"/>
           </a:xfrm>
           <a:prstGeom prst="rect">
             <a:avLst/>
@@ -5472,7 +5787,7 @@
               </a:defRPr>
             </a:pPr>
             <a:r>
-              <a:t>Convene a joint risk review for integration tasks across both projects this week.</a:t>
+              <a:t>Triage 54 active at-risk tasks with abhilasha.s@zycus.com; escalate any CP tasks that are Red or slipping.</a:t>
             </a:r>
           </a:p>
         </p:txBody>
@@ -5485,8 +5800,8 @@
         </p:nvSpPr>
         <p:spPr>
           <a:xfrm>
-            <a:off x="457200" y="4407408"/>
-            <a:ext cx="2743200" cy="320040"/>
+            <a:off x="457200" y="4443984"/>
+            <a:ext cx="2651760" cy="320040"/>
           </a:xfrm>
           <a:prstGeom prst="rect">
             <a:avLst/>
@@ -5507,7 +5822,7 @@
               </a:defRPr>
             </a:pPr>
             <a:r>
-              <a:t>✅ Action 2</a:t>
+              <a:t>✅ UniSan S2P</a:t>
             </a:r>
           </a:p>
         </p:txBody>
@@ -5520,8 +5835,8 @@
         </p:nvSpPr>
         <p:spPr>
           <a:xfrm>
-            <a:off x="3291840" y="4407408"/>
-            <a:ext cx="8412480" cy="502920"/>
+            <a:off x="3200400" y="4443984"/>
+            <a:ext cx="8503920" cy="502920"/>
           </a:xfrm>
           <a:prstGeom prst="rect">
             <a:avLst/>
@@ -5542,7 +5857,7 @@
               </a:defRPr>
             </a:pPr>
             <a:r>
-              <a:t>Escalate UniSan's Not-Started backlog to PM and client; confirm whether parallel workstreams can be activated.</a:t>
+              <a:t>Triage 51 active at-risk tasks with UniSan Integration Team; escalate any CP tasks that are Red or slipping.</a:t>
             </a:r>
           </a:p>
         </p:txBody>
@@ -5555,8 +5870,8 @@
         </p:nvSpPr>
         <p:spPr>
           <a:xfrm>
-            <a:off x="457200" y="5065776"/>
-            <a:ext cx="2743200" cy="320040"/>
+            <a:off x="457200" y="5102352"/>
+            <a:ext cx="2651760" cy="320040"/>
           </a:xfrm>
           <a:prstGeom prst="rect">
             <a:avLst/>
@@ -5577,7 +5892,7 @@
               </a:defRPr>
             </a:pPr>
             <a:r>
-              <a:t>✅ Action 3</a:t>
+              <a:t>✅ Data Quality</a:t>
             </a:r>
           </a:p>
         </p:txBody>
@@ -5590,8 +5905,8 @@
         </p:nvSpPr>
         <p:spPr>
           <a:xfrm>
-            <a:off x="3291840" y="5065776"/>
-            <a:ext cx="8412480" cy="502920"/>
+            <a:off x="3200400" y="5102352"/>
+            <a:ext cx="8503920" cy="502920"/>
           </a:xfrm>
           <a:prstGeom prst="rect">
             <a:avLst/>
@@ -5612,7 +5927,7 @@
               </a:defRPr>
             </a:pPr>
             <a:r>
-              <a:t>Chase OTK data sample (due Jul 10) and JDE mapping — both are on the critical path.</a:t>
+              <a:t>Ensure Predecessors column is populated in MS Project exports to enable dependency-aware simulation on all projects.</a:t>
             </a:r>
           </a:p>
         </p:txBody>
@@ -5708,31 +6023,27 @@
               </a:defRPr>
             </a:pPr>
             <a:r>
-              <a:t>RAG Score = 0.60 x Forward Risk + 0.40 x Historical Slip</a:t>
+              <a:t>RAG Score = 0.60 × Forward Risk + 0.40 × Historical Slip. Forward Risk: fraction of critical-path active tasks that are Red (×1.0) or Amber (×0.5). Falls back to all active tasks if critical count &lt;5.</a:t>
             </a:r>
             <a:br/>
             <a:r>
-              <a:t>Forward Risk: fraction of critical-path active tasks that are Red (weight 1.0) or Amber (0.5). Falls back to all active tasks if critical count &lt; 5.</a:t>
+              <a:t>Historical Slip: median(|variance_days|) for late completed tasks, normalised against 30-day ceiling. Variance column sign used (verified: 196/199 rows correct). Magnitude treated as unreliable for parent rows.</a:t>
             </a:r>
             <a:br/>
             <a:r>
-              <a:t>Historical Slip: median(variance_days.abs()) for late completed critical tasks, normalised against 30-day ceiling. Uses Variance column sign (verified reliable: 196/199 rows confirmed) + magnitude. Note: actual_minus_planned was initially used here but is wrong for slip — it measures duration efficiency (elapsed vs planned), not lateness vs Baseline Finish date. Reverted.</a:t>
+              <a:t>ML Model top features (GBT, verified this run): total_float_days (0.5439), variance_sign_code (0.2716), pct_complete (0.1054). RAG is manually set by PMs — model learns PM judgment patterns, not a formula. Fit/interpret only — 2 projects, no holdout split.</a:t>
             </a:r>
             <a:br/>
             <a:r>
-              <a:t>ML Model: GradientBoostingClassifier. Feature importance (verified 2026-07-08): total_float_days (0.54) &gt; variance_sign_code (0.27) &gt; pct_complete (0.11). RAG is manually set by PMs — model learns PM judgment patterns, not a formula. FIT/INTERPRET ONLY on 2-project data, no holdout validation.</a:t>
+              <a:t>Monte Carlo v1: throughput rate (tasks/week) × log-normal duration-ratio distribution. MC v2 (DAG): discrete-event simulation propagating durations topologically through predecessor graph. v2 runs only when predecessor coverage ≥50%; otherwise v1 is sole forecast.</a:t>
             </a:r>
             <a:br/>
             <a:r>
-              <a:t>Monte Carlo: 10,000 simulations. Uses throughput rate (tasks/week from End Date history) to estimate remaining calendar time — avoids serial-sum overcount from parallel team execution. Duration ratio (log-normal) applied as pace variance multiplier. Stability check flags acceleration/deceleration &gt; 2x in caveat.</a:t>
+              <a:t>Clustering: TF-IDF + KMeans on available fields (Area, Phase, Owner, Task Name). Sparsity-aware: fields missing in &gt;98% of rows excluded; caveat lists actual population %.</a:t>
             </a:r>
             <a:br/>
             <a:r>
-              <a:t>Column aliases: Project B (UniSan) uses 'Schedule Health' instead of 'RAG'; both encode Red/Yellow/Green task health. Variance2 column promoted over project-level Variance stub.</a:t>
-            </a:r>
-            <a:br/>
-            <a:r>
-              <a:t>Clustering: TF-IDF + KMeans on Area/Phase/Owner metadata. Comment clustering skipped (sparse: 10 rows S2P, 0 rows UniSan).</a:t>
+              <a:t>Data confidence tiers — High: weighted null rate &lt;20%; Medium: 20–45%; Low: &gt;45%. Predecessor coverage weighted 0.4; planned_days + pct_complete 0.3 each.</a:t>
             </a:r>
           </a:p>
         </p:txBody>

</xml_diff>

<commit_message>
chore: update sample outputs to latest run (2026-07-10)
</commit_message>
<xml_diff>
--- a/outputs/monthly/Executive_Report_2026-07.pptx
+++ b/outputs/monthly/Executive_Report_2026-07.pptx
@@ -3445,7 +3445,7 @@
               </a:defRPr>
             </a:pPr>
             <a:r>
-              <a:t>Confidential | 08 Jul 2026</a:t>
+              <a:t>Confidential | 10 Jul 2026</a:t>
             </a:r>
           </a:p>
         </p:txBody>
@@ -3654,7 +3654,7 @@
               </a:defRPr>
             </a:pPr>
             <a:r>
-              <a:t>Score: 0.37/1.00   P(on-time): 78%</a:t>
+              <a:t>Score: 0.37/1.00   P(on-time): 76%</a:t>
             </a:r>
           </a:p>
         </p:txBody>
@@ -3767,7 +3767,7 @@
               </a:defRPr>
             </a:pPr>
             <a:r>
-              <a:t>Score: 0.04/1.00   P(on-time) DAG: 15%  |  v1: 5%</a:t>
+              <a:t>Score: 0.04/1.00   P(on-time) DAG: 7%  |  v1: 4%</a:t>
             </a:r>
           </a:p>
         </p:txBody>
@@ -3898,7 +3898,7 @@
               </a:defRPr>
             </a:pPr>
             <a:r>
-              <a:t>🟡  Outokumpu S2P — AMBER: 54 active at-risk tasks, 60 Red. Top cluster: 28 tasks under abhilasha.s@zycus.com. 78% P(on-time).</a:t>
+              <a:t>🟡  Outokumpu S2P — AMBER: 54 active at-risk tasks, 60 Red. Top cluster: 28 tasks under abhilasha.s@zycus.com. 76% P(on-time).</a:t>
             </a:r>
           </a:p>
         </p:txBody>
@@ -3933,7 +3933,7 @@
               </a:defRPr>
             </a:pPr>
             <a:r>
-              <a:t>🟢  UniSan S2P — GREEN: 51 active at-risk tasks, 42 Red. Top cluster: 26 tasks under UniSan Integration Team. 5% P(on-time).</a:t>
+              <a:t>🟢  UniSan S2P — GREEN: 51 active at-risk tasks, 42 Red. Top cluster: 26 tasks under UniSan Integration Team. 4% P(on-time).</a:t>
             </a:r>
           </a:p>
         </p:txBody>
@@ -4455,7 +4455,7 @@
               </a:defRPr>
             </a:pPr>
             <a:r>
-              <a:t>78%</a:t>
+              <a:t>76%</a:t>
             </a:r>
           </a:p>
         </p:txBody>
@@ -4595,7 +4595,7 @@
               </a:defRPr>
             </a:pPr>
             <a:r>
-              <a:t>15% (DAG)</a:t>
+              <a:t>7% (DAG)</a:t>
             </a:r>
           </a:p>
         </p:txBody>
@@ -4841,7 +4841,7 @@
               </a:defRPr>
             </a:pPr>
             <a:r>
-              <a:t>v1 (throughput): 78%  |  v2 skipped (low predecessor coverage)</a:t>
+              <a:t>v1 (throughput): 76%  |  v2 skipped (low predecessor coverage)</a:t>
             </a:r>
           </a:p>
         </p:txBody>
@@ -4911,7 +4911,7 @@
               </a:defRPr>
             </a:pPr>
             <a:r>
-              <a:t>78%</a:t>
+              <a:t>76%</a:t>
             </a:r>
           </a:p>
         </p:txBody>
@@ -4981,7 +4981,7 @@
               </a:defRPr>
             </a:pPr>
             <a:r>
-              <a:t>5%</a:t>
+              <a:t>6%</a:t>
             </a:r>
           </a:p>
         </p:txBody>
@@ -5051,7 +5051,7 @@
               </a:defRPr>
             </a:pPr>
             <a:r>
-              <a:t>13%</a:t>
+              <a:t>14%</a:t>
             </a:r>
           </a:p>
         </p:txBody>
@@ -5201,7 +5201,7 @@
               </a:defRPr>
             </a:pPr>
             <a:r>
-              <a:t>v1 (throughput): 5%  →  v2 (DAG): 15%  (+10 pp from dependency structure)</a:t>
+              <a:t>v1 (throughput): 4%  →  v2 (DAG): 7%  (+3 pp from dependency structure)</a:t>
             </a:r>
           </a:p>
         </p:txBody>
@@ -5271,7 +5271,7 @@
               </a:defRPr>
             </a:pPr>
             <a:r>
-              <a:t>5%</a:t>
+              <a:t>4%</a:t>
             </a:r>
           </a:p>
         </p:txBody>
@@ -5411,7 +5411,7 @@
               </a:defRPr>
             </a:pPr>
             <a:r>
-              <a:t>88%</a:t>
+              <a:t>89%</a:t>
             </a:r>
           </a:p>
         </p:txBody>
@@ -5542,7 +5542,7 @@
               </a:defRPr>
             </a:pPr>
             <a:r>
-              <a:t>Outokumpu S2P is the highest-risk project (score 0.367). P(on-time) 78% (throughput model). Deadline: 2026-12-07.</a:t>
+              <a:t>Outokumpu S2P is the highest-risk project (score 0.367). P(on-time) 76% (throughput model). Deadline: 2026-12-07.</a:t>
             </a:r>
           </a:p>
         </p:txBody>

</xml_diff>